<commit_message>
Update agent harness diagram PPTX
</commit_message>
<xml_diff>
--- a/agent-harness-diagram.pptx
+++ b/agent-harness-diagram.pptx
@@ -860,7 +860,7 @@
           <a:p>
             <a:r>
               <a:rPr lang="en-US" dirty="0"/>
-              <a:t>Enforcement workflow. Spoke teams raise three kinds of request: policy and budget updates, MCP server onboarding, and agent or team onboarding. Each becomes a GitOps PR in kong-services, passes automated policy and two-lines-of-assurance vetting, and is promoted to the gateway by decK sync. The data plane then enforces SPIFFE workload attestation, central Splunk HEC telemetry, token quotas and loop defenses, and dynamic vault secrets with tool ACLs. Out of band, the automated kill switch API and SRE revocation path severs a consumer at the gateway in under five seconds without waiting for a pipeline run.</a:t>
+              <a:t>Enforcement workflow. Spoke teams raise five kinds of request: policy and budget updates, model onboarding (adding something like Gemini 3.8 Flash to the routing pool with its own caps and evals), model deprecation (retiring something like Gemini 2.5 Pro by redirecting traffic before the route is removed), MCP server onboarding, and agent or team onboarding. Each becomes a GitOps PR in kong-services, passes automated policy and two-lines-of-assurance vetting, and is promoted to the gateway by decK sync. The data plane then enforces SPIFFE workload attestation, central Splunk HEC telemetry, token quotas and loop defenses, and dynamic vault secrets with tool ACLs. Out of band, the automated kill switch API and SRE revocation path severs a consumer at the gateway in under five seconds without waiting for a pipeline run.</a:t>
             </a:r>
             <a:endParaRPr lang="en-US" dirty="0"/>
           </a:p>
@@ -10970,7 +10970,7 @@
         <p:spPr>
           <a:xfrm>
             <a:off x="457200" y="868680"/>
-            <a:ext cx="3566160" cy="3611880"/>
+            <a:ext cx="3566160" cy="3749040"/>
           </a:xfrm>
           <a:prstGeom prst="roundRect">
             <a:avLst>
@@ -11127,11 +11127,11 @@
         <p:spPr>
           <a:xfrm>
             <a:off x="658368" y="1645920"/>
-            <a:ext cx="3163824" cy="749808"/>
+            <a:ext cx="3163824" cy="493776"/>
           </a:xfrm>
           <a:prstGeom prst="roundRect">
             <a:avLst>
-              <a:gd name="adj" fmla="val 9756"/>
+              <a:gd name="adj" fmla="val 14815"/>
             </a:avLst>
           </a:prstGeom>
           <a:solidFill>
@@ -11161,7 +11161,7 @@
         </p:blipFill>
         <p:spPr>
           <a:xfrm>
-            <a:off x="786384" y="1920240"/>
+            <a:off x="786384" y="1792224"/>
             <a:ext cx="201168" cy="201168"/>
           </a:xfrm>
           <a:prstGeom prst="rect">
@@ -11178,7 +11178,7 @@
         <p:spPr>
           <a:xfrm>
             <a:off x="1097280" y="1645920"/>
-            <a:ext cx="2615184" cy="749808"/>
+            <a:ext cx="2615184" cy="493776"/>
           </a:xfrm>
           <a:prstGeom prst="rect">
             <a:avLst/>
@@ -11239,12 +11239,12 @@
         </p:nvSpPr>
         <p:spPr>
           <a:xfrm>
-            <a:off x="658368" y="2587752"/>
-            <a:ext cx="3163824" cy="749808"/>
+            <a:off x="658368" y="2231136"/>
+            <a:ext cx="3163824" cy="493776"/>
           </a:xfrm>
           <a:prstGeom prst="roundRect">
             <a:avLst>
-              <a:gd name="adj" fmla="val 9756"/>
+              <a:gd name="adj" fmla="val 14815"/>
             </a:avLst>
           </a:prstGeom>
           <a:solidFill>
@@ -11274,7 +11274,7 @@
         </p:blipFill>
         <p:spPr>
           <a:xfrm>
-            <a:off x="786384" y="2862072"/>
+            <a:off x="786384" y="2377440"/>
             <a:ext cx="201168" cy="201168"/>
           </a:xfrm>
           <a:prstGeom prst="rect">
@@ -11290,8 +11290,8 @@
         </p:nvSpPr>
         <p:spPr>
           <a:xfrm>
-            <a:off x="1097280" y="2587752"/>
-            <a:ext cx="2615184" cy="749808"/>
+            <a:off x="1097280" y="2231136"/>
+            <a:ext cx="2615184" cy="493776"/>
           </a:xfrm>
           <a:prstGeom prst="rect">
             <a:avLst/>
@@ -11318,7 +11318,7 @@
                 <a:ea typeface="Calibri" pitchFamily="34" charset="-122"/>
                 <a:cs typeface="Calibri" pitchFamily="34" charset="-120"/>
               </a:rPr>
-              <a:t>MCP server onboarding</a:t>
+              <a:t>Model onboarding</a:t>
             </a:r>
             <a:endParaRPr lang="en-US" sz="1150" dirty="0"/>
           </a:p>
@@ -11338,7 +11338,7 @@
                 <a:ea typeface="Calibri" pitchFamily="34" charset="-122"/>
                 <a:cs typeface="Calibri" pitchFamily="34" charset="-120"/>
               </a:rPr>
-              <a:t>Tool RBAC, vault injection</a:t>
+              <a:t>e.g. add Gemini 3.8 Flash — route, caps, evals</a:t>
             </a:r>
             <a:endParaRPr lang="en-US" sz="1150" dirty="0"/>
           </a:p>
@@ -11352,12 +11352,12 @@
         </p:nvSpPr>
         <p:spPr>
           <a:xfrm>
-            <a:off x="658368" y="3529584"/>
-            <a:ext cx="3163824" cy="749808"/>
+            <a:off x="658368" y="2816352"/>
+            <a:ext cx="3163824" cy="493776"/>
           </a:xfrm>
           <a:prstGeom prst="roundRect">
             <a:avLst>
-              <a:gd name="adj" fmla="val 9756"/>
+              <a:gd name="adj" fmla="val 14815"/>
             </a:avLst>
           </a:prstGeom>
           <a:solidFill>
@@ -11387,7 +11387,7 @@
         </p:blipFill>
         <p:spPr>
           <a:xfrm>
-            <a:off x="786384" y="3803904"/>
+            <a:off x="786384" y="2962656"/>
             <a:ext cx="201168" cy="201168"/>
           </a:xfrm>
           <a:prstGeom prst="rect">
@@ -11403,8 +11403,8 @@
         </p:nvSpPr>
         <p:spPr>
           <a:xfrm>
-            <a:off x="1097280" y="3529584"/>
-            <a:ext cx="2615184" cy="749808"/>
+            <a:off x="1097280" y="2816352"/>
+            <a:ext cx="2615184" cy="493776"/>
           </a:xfrm>
           <a:prstGeom prst="rect">
             <a:avLst/>
@@ -11431,7 +11431,7 @@
                 <a:ea typeface="Calibri" pitchFamily="34" charset="-122"/>
                 <a:cs typeface="Calibri" pitchFamily="34" charset="-120"/>
               </a:rPr>
-              <a:t>Agent / team onboarding</a:t>
+              <a:t>Model deprecation</a:t>
             </a:r>
             <a:endParaRPr lang="en-US" sz="1150" dirty="0"/>
           </a:p>
@@ -11451,7 +11451,7 @@
                 <a:ea typeface="Calibri" pitchFamily="34" charset="-122"/>
                 <a:cs typeface="Calibri" pitchFamily="34" charset="-120"/>
               </a:rPr>
-              <a:t>Spoke project, transit, quotas</a:t>
+              <a:t>e.g. retire Gemini 2.5 Pro — redirect, then remove</a:t>
             </a:r>
             <a:endParaRPr lang="en-US" sz="1150" dirty="0"/>
           </a:p>
@@ -11465,12 +11465,12 @@
         </p:nvSpPr>
         <p:spPr>
           <a:xfrm>
-            <a:off x="4480560" y="868680"/>
-            <a:ext cx="3566160" cy="3611880"/>
+            <a:off x="658368" y="3401568"/>
+            <a:ext cx="3163824" cy="493776"/>
           </a:xfrm>
           <a:prstGeom prst="roundRect">
             <a:avLst>
-              <a:gd name="adj" fmla="val 3077"/>
+              <a:gd name="adj" fmla="val 14815"/>
             </a:avLst>
           </a:prstGeom>
           <a:solidFill>
@@ -11484,166 +11484,9 @@
           </a:ln>
         </p:spPr>
       </p:sp>
-      <p:sp>
-        <p:nvSpPr>
-          <p:cNvPr id="18" name="Shape 13"/>
-          <p:cNvSpPr/>
-          <p:nvPr/>
-        </p:nvSpPr>
-        <p:spPr>
-          <a:xfrm>
-            <a:off x="4608576" y="1024128"/>
-            <a:ext cx="3310128" cy="502920"/>
-          </a:xfrm>
-          <a:prstGeom prst="roundRect">
-            <a:avLst>
-              <a:gd name="adj" fmla="val 14545"/>
-            </a:avLst>
-          </a:prstGeom>
-          <a:solidFill>
-            <a:srgbClr val="ECF9F3"/>
-          </a:solidFill>
-          <a:ln w="15875">
-            <a:solidFill>
-              <a:srgbClr val="A8DDCB"/>
-            </a:solidFill>
-            <a:prstDash val="solid"/>
-          </a:ln>
-        </p:spPr>
-      </p:sp>
-      <p:sp>
-        <p:nvSpPr>
-          <p:cNvPr id="19" name="Shape 14"/>
-          <p:cNvSpPr/>
-          <p:nvPr/>
-        </p:nvSpPr>
-        <p:spPr>
-          <a:xfrm>
-            <a:off x="4700016" y="1097280"/>
-            <a:ext cx="347472" cy="347472"/>
-          </a:xfrm>
-          <a:prstGeom prst="ellipse">
-            <a:avLst/>
-          </a:prstGeom>
-          <a:solidFill>
-            <a:srgbClr val="0F9D76"/>
-          </a:solidFill>
-          <a:ln w="12700">
-            <a:solidFill>
-              <a:srgbClr val="0F9D76"/>
-            </a:solidFill>
-            <a:prstDash val="solid"/>
-          </a:ln>
-        </p:spPr>
-      </p:sp>
-      <p:sp>
-        <p:nvSpPr>
-          <p:cNvPr id="20" name="Text 15"/>
-          <p:cNvSpPr txBox="1"/>
-          <p:nvPr/>
-        </p:nvSpPr>
-        <p:spPr>
-          <a:xfrm>
-            <a:off x="4700016" y="1097280"/>
-            <a:ext cx="347472" cy="347472"/>
-          </a:xfrm>
-          <a:prstGeom prst="rect">
-            <a:avLst/>
-          </a:prstGeom>
-          <a:noFill/>
-          <a:ln/>
-        </p:spPr>
-        <p:txBody>
-          <a:bodyPr wrap="square" lIns="0" tIns="0" rIns="0" bIns="0" rtlCol="0" anchor="ctr"/>
-          <a:lstStyle/>
-          <a:p>
-            <a:pPr algn="ctr" indent="0" marL="0">
-              <a:buNone/>
-            </a:pPr>
-            <a:r>
-              <a:rPr lang="en-US" sz="1300" b="1" dirty="0">
-                <a:solidFill>
-                  <a:srgbClr val="FFFFFF"/>
-                </a:solidFill>
-                <a:latin typeface="Calibri" pitchFamily="34" charset="0"/>
-                <a:ea typeface="Calibri" pitchFamily="34" charset="-122"/>
-                <a:cs typeface="Calibri" pitchFamily="34" charset="-120"/>
-              </a:rPr>
-              <a:t>2</a:t>
-            </a:r>
-            <a:endParaRPr lang="en-US" sz="1300" dirty="0"/>
-          </a:p>
-        </p:txBody>
-      </p:sp>
-      <p:sp>
-        <p:nvSpPr>
-          <p:cNvPr id="21" name="Text 16"/>
-          <p:cNvSpPr txBox="1"/>
-          <p:nvPr/>
-        </p:nvSpPr>
-        <p:spPr>
-          <a:xfrm>
-            <a:off x="5157216" y="1024128"/>
-            <a:ext cx="2743200" cy="502920"/>
-          </a:xfrm>
-          <a:prstGeom prst="rect">
-            <a:avLst/>
-          </a:prstGeom>
-          <a:noFill/>
-          <a:ln/>
-        </p:spPr>
-        <p:txBody>
-          <a:bodyPr wrap="square" lIns="0" tIns="0" rIns="0" bIns="0" rtlCol="0" anchor="ctr"/>
-          <a:lstStyle/>
-          <a:p>
-            <a:pPr indent="0" marL="0">
-              <a:buNone/>
-            </a:pPr>
-            <a:r>
-              <a:rPr lang="en-US" sz="1250" b="1" dirty="0">
-                <a:solidFill>
-                  <a:srgbClr val="0A7355"/>
-                </a:solidFill>
-                <a:latin typeface="Calibri" pitchFamily="34" charset="0"/>
-                <a:ea typeface="Calibri" pitchFamily="34" charset="-122"/>
-                <a:cs typeface="Calibri" pitchFamily="34" charset="-120"/>
-              </a:rPr>
-              <a:t>AI hub CI/CD (GitOps spine)</a:t>
-            </a:r>
-            <a:endParaRPr lang="en-US" sz="1250" dirty="0"/>
-          </a:p>
-        </p:txBody>
-      </p:sp>
-      <p:sp>
-        <p:nvSpPr>
-          <p:cNvPr id="22" name="Shape 17"/>
-          <p:cNvSpPr/>
-          <p:nvPr/>
-        </p:nvSpPr>
-        <p:spPr>
-          <a:xfrm>
-            <a:off x="4681728" y="1627632"/>
-            <a:ext cx="3163824" cy="685800"/>
-          </a:xfrm>
-          <a:prstGeom prst="roundRect">
-            <a:avLst>
-              <a:gd name="adj" fmla="val 10667"/>
-            </a:avLst>
-          </a:prstGeom>
-          <a:solidFill>
-            <a:srgbClr val="FFFFFF"/>
-          </a:solidFill>
-          <a:ln w="15875">
-            <a:solidFill>
-              <a:srgbClr val="C7D2E8"/>
-            </a:solidFill>
-            <a:prstDash val="solid"/>
-          </a:ln>
-        </p:spPr>
-      </p:sp>
       <p:pic>
         <p:nvPicPr>
-          <p:cNvPr id="23" name="Image 3" descr="preencoded.png">    </p:cNvPr>
+          <p:cNvPr id="18" name="Image 3" descr="preencoded.png">    </p:cNvPr>
           <p:cNvPicPr>
             <a:picLocks noChangeAspect="1"/>
           </p:cNvPicPr>
@@ -11657,7 +11500,7 @@
         </p:blipFill>
         <p:spPr>
           <a:xfrm>
-            <a:off x="4809744" y="1869948"/>
+            <a:off x="786384" y="3547872"/>
             <a:ext cx="201168" cy="201168"/>
           </a:xfrm>
           <a:prstGeom prst="rect">
@@ -11667,14 +11510,14 @@
       </p:pic>
       <p:sp>
         <p:nvSpPr>
-          <p:cNvPr id="24" name="Text 18"/>
+          <p:cNvPr id="19" name="Text 13"/>
           <p:cNvSpPr txBox="1"/>
           <p:nvPr/>
         </p:nvSpPr>
         <p:spPr>
           <a:xfrm>
-            <a:off x="5120640" y="1627632"/>
-            <a:ext cx="2615184" cy="685800"/>
+            <a:off x="1097280" y="3401568"/>
+            <a:ext cx="2615184" cy="493776"/>
           </a:xfrm>
           <a:prstGeom prst="rect">
             <a:avLst/>
@@ -11701,7 +11544,7 @@
                 <a:ea typeface="Calibri" pitchFamily="34" charset="-122"/>
                 <a:cs typeface="Calibri" pitchFamily="34" charset="-120"/>
               </a:rPr>
-              <a:t>GitOps PR in kong-services</a:t>
+              <a:t>MCP server onboarding</a:t>
             </a:r>
             <a:endParaRPr lang="en-US" sz="1150" dirty="0"/>
           </a:p>
@@ -11721,7 +11564,7 @@
                 <a:ea typeface="Calibri" pitchFamily="34" charset="-122"/>
                 <a:cs typeface="Calibri" pitchFamily="34" charset="-120"/>
               </a:rPr>
-              <a:t>Declarative config change proposed</a:t>
+              <a:t>Tool RBAC, vault injection</a:t>
             </a:r>
             <a:endParaRPr lang="en-US" sz="1150" dirty="0"/>
           </a:p>
@@ -11729,42 +11572,18 @@
       </p:sp>
       <p:sp>
         <p:nvSpPr>
-          <p:cNvPr id="25" name="Shape 19"/>
-          <p:cNvSpPr/>
-          <p:nvPr/>
-        </p:nvSpPr>
-        <p:spPr>
-          <a:xfrm>
-            <a:off x="6263640" y="2350008"/>
-            <a:ext cx="0" cy="192024"/>
-          </a:xfrm>
-          <a:prstGeom prst="line">
-            <a:avLst/>
-          </a:prstGeom>
-          <a:noFill/>
-          <a:ln w="22225">
-            <a:solidFill>
-              <a:srgbClr val="2B3A67"/>
-            </a:solidFill>
-            <a:prstDash val="solid"/>
-            <a:tailEnd type="triangle"/>
-          </a:ln>
-        </p:spPr>
-      </p:sp>
-      <p:sp>
-        <p:nvSpPr>
-          <p:cNvPr id="26" name="Shape 20"/>
-          <p:cNvSpPr/>
-          <p:nvPr/>
-        </p:nvSpPr>
-        <p:spPr>
-          <a:xfrm>
-            <a:off x="4681728" y="2587752"/>
-            <a:ext cx="3163824" cy="685800"/>
+          <p:cNvPr id="20" name="Shape 14"/>
+          <p:cNvSpPr/>
+          <p:nvPr/>
+        </p:nvSpPr>
+        <p:spPr>
+          <a:xfrm>
+            <a:off x="658368" y="3986784"/>
+            <a:ext cx="3163824" cy="493776"/>
           </a:xfrm>
           <a:prstGeom prst="roundRect">
             <a:avLst>
-              <a:gd name="adj" fmla="val 10667"/>
+              <a:gd name="adj" fmla="val 14815"/>
             </a:avLst>
           </a:prstGeom>
           <a:solidFill>
@@ -11780,7 +11599,7 @@
       </p:sp>
       <p:pic>
         <p:nvPicPr>
-          <p:cNvPr id="27" name="Image 4" descr="preencoded.png">    </p:cNvPr>
+          <p:cNvPr id="21" name="Image 4" descr="preencoded.png">    </p:cNvPr>
           <p:cNvPicPr>
             <a:picLocks noChangeAspect="1"/>
           </p:cNvPicPr>
@@ -11794,7 +11613,7 @@
         </p:blipFill>
         <p:spPr>
           <a:xfrm>
-            <a:off x="4809744" y="2830068"/>
+            <a:off x="786384" y="4133088"/>
             <a:ext cx="201168" cy="201168"/>
           </a:xfrm>
           <a:prstGeom prst="rect">
@@ -11804,14 +11623,14 @@
       </p:pic>
       <p:sp>
         <p:nvSpPr>
-          <p:cNvPr id="28" name="Text 21"/>
+          <p:cNvPr id="22" name="Text 15"/>
           <p:cNvSpPr txBox="1"/>
           <p:nvPr/>
         </p:nvSpPr>
         <p:spPr>
           <a:xfrm>
-            <a:off x="5120640" y="2587752"/>
-            <a:ext cx="2615184" cy="685800"/>
+            <a:off x="1097280" y="3986784"/>
+            <a:ext cx="2615184" cy="493776"/>
           </a:xfrm>
           <a:prstGeom prst="rect">
             <a:avLst/>
@@ -11838,7 +11657,7 @@
                 <a:ea typeface="Calibri" pitchFamily="34" charset="-122"/>
                 <a:cs typeface="Calibri" pitchFamily="34" charset="-120"/>
               </a:rPr>
-              <a:t>Automated policy &amp; 2LoA vetting</a:t>
+              <a:t>Agent / team onboarding</a:t>
             </a:r>
             <a:endParaRPr lang="en-US" sz="1150" dirty="0"/>
           </a:p>
@@ -11858,7 +11677,7 @@
                 <a:ea typeface="Calibri" pitchFamily="34" charset="-122"/>
                 <a:cs typeface="Calibri" pitchFamily="34" charset="-120"/>
               </a:rPr>
-              <a:t>Schema checks and dual approval</a:t>
+              <a:t>Spoke project, transit, quotas</a:t>
             </a:r>
             <a:endParaRPr lang="en-US" sz="1150" dirty="0"/>
           </a:p>
@@ -11866,42 +11685,18 @@
       </p:sp>
       <p:sp>
         <p:nvSpPr>
-          <p:cNvPr id="29" name="Shape 22"/>
-          <p:cNvSpPr/>
-          <p:nvPr/>
-        </p:nvSpPr>
-        <p:spPr>
-          <a:xfrm>
-            <a:off x="6263640" y="3310128"/>
-            <a:ext cx="0" cy="192024"/>
-          </a:xfrm>
-          <a:prstGeom prst="line">
-            <a:avLst/>
-          </a:prstGeom>
-          <a:noFill/>
-          <a:ln w="22225">
-            <a:solidFill>
-              <a:srgbClr val="2B3A67"/>
-            </a:solidFill>
-            <a:prstDash val="solid"/>
-            <a:tailEnd type="triangle"/>
-          </a:ln>
-        </p:spPr>
-      </p:sp>
-      <p:sp>
-        <p:nvSpPr>
-          <p:cNvPr id="30" name="Shape 23"/>
-          <p:cNvSpPr/>
-          <p:nvPr/>
-        </p:nvSpPr>
-        <p:spPr>
-          <a:xfrm>
-            <a:off x="4681728" y="3547872"/>
-            <a:ext cx="3163824" cy="685800"/>
+          <p:cNvPr id="23" name="Shape 16"/>
+          <p:cNvSpPr/>
+          <p:nvPr/>
+        </p:nvSpPr>
+        <p:spPr>
+          <a:xfrm>
+            <a:off x="4480560" y="868680"/>
+            <a:ext cx="3566160" cy="3749040"/>
           </a:xfrm>
           <a:prstGeom prst="roundRect">
             <a:avLst>
-              <a:gd name="adj" fmla="val 10667"/>
+              <a:gd name="adj" fmla="val 3077"/>
             </a:avLst>
           </a:prstGeom>
           <a:solidFill>
@@ -11915,9 +11710,166 @@
           </a:ln>
         </p:spPr>
       </p:sp>
+      <p:sp>
+        <p:nvSpPr>
+          <p:cNvPr id="24" name="Shape 17"/>
+          <p:cNvSpPr/>
+          <p:nvPr/>
+        </p:nvSpPr>
+        <p:spPr>
+          <a:xfrm>
+            <a:off x="4608576" y="1024128"/>
+            <a:ext cx="3310128" cy="502920"/>
+          </a:xfrm>
+          <a:prstGeom prst="roundRect">
+            <a:avLst>
+              <a:gd name="adj" fmla="val 14545"/>
+            </a:avLst>
+          </a:prstGeom>
+          <a:solidFill>
+            <a:srgbClr val="ECF9F3"/>
+          </a:solidFill>
+          <a:ln w="15875">
+            <a:solidFill>
+              <a:srgbClr val="A8DDCB"/>
+            </a:solidFill>
+            <a:prstDash val="solid"/>
+          </a:ln>
+        </p:spPr>
+      </p:sp>
+      <p:sp>
+        <p:nvSpPr>
+          <p:cNvPr id="25" name="Shape 18"/>
+          <p:cNvSpPr/>
+          <p:nvPr/>
+        </p:nvSpPr>
+        <p:spPr>
+          <a:xfrm>
+            <a:off x="4700016" y="1097280"/>
+            <a:ext cx="347472" cy="347472"/>
+          </a:xfrm>
+          <a:prstGeom prst="ellipse">
+            <a:avLst/>
+          </a:prstGeom>
+          <a:solidFill>
+            <a:srgbClr val="0F9D76"/>
+          </a:solidFill>
+          <a:ln w="12700">
+            <a:solidFill>
+              <a:srgbClr val="0F9D76"/>
+            </a:solidFill>
+            <a:prstDash val="solid"/>
+          </a:ln>
+        </p:spPr>
+      </p:sp>
+      <p:sp>
+        <p:nvSpPr>
+          <p:cNvPr id="26" name="Text 19"/>
+          <p:cNvSpPr txBox="1"/>
+          <p:nvPr/>
+        </p:nvSpPr>
+        <p:spPr>
+          <a:xfrm>
+            <a:off x="4700016" y="1097280"/>
+            <a:ext cx="347472" cy="347472"/>
+          </a:xfrm>
+          <a:prstGeom prst="rect">
+            <a:avLst/>
+          </a:prstGeom>
+          <a:noFill/>
+          <a:ln/>
+        </p:spPr>
+        <p:txBody>
+          <a:bodyPr wrap="square" lIns="0" tIns="0" rIns="0" bIns="0" rtlCol="0" anchor="ctr"/>
+          <a:lstStyle/>
+          <a:p>
+            <a:pPr algn="ctr" indent="0" marL="0">
+              <a:buNone/>
+            </a:pPr>
+            <a:r>
+              <a:rPr lang="en-US" sz="1300" b="1" dirty="0">
+                <a:solidFill>
+                  <a:srgbClr val="FFFFFF"/>
+                </a:solidFill>
+                <a:latin typeface="Calibri" pitchFamily="34" charset="0"/>
+                <a:ea typeface="Calibri" pitchFamily="34" charset="-122"/>
+                <a:cs typeface="Calibri" pitchFamily="34" charset="-120"/>
+              </a:rPr>
+              <a:t>2</a:t>
+            </a:r>
+            <a:endParaRPr lang="en-US" sz="1300" dirty="0"/>
+          </a:p>
+        </p:txBody>
+      </p:sp>
+      <p:sp>
+        <p:nvSpPr>
+          <p:cNvPr id="27" name="Text 20"/>
+          <p:cNvSpPr txBox="1"/>
+          <p:nvPr/>
+        </p:nvSpPr>
+        <p:spPr>
+          <a:xfrm>
+            <a:off x="5157216" y="1024128"/>
+            <a:ext cx="2743200" cy="502920"/>
+          </a:xfrm>
+          <a:prstGeom prst="rect">
+            <a:avLst/>
+          </a:prstGeom>
+          <a:noFill/>
+          <a:ln/>
+        </p:spPr>
+        <p:txBody>
+          <a:bodyPr wrap="square" lIns="0" tIns="0" rIns="0" bIns="0" rtlCol="0" anchor="ctr"/>
+          <a:lstStyle/>
+          <a:p>
+            <a:pPr indent="0" marL="0">
+              <a:buNone/>
+            </a:pPr>
+            <a:r>
+              <a:rPr lang="en-US" sz="1250" b="1" dirty="0">
+                <a:solidFill>
+                  <a:srgbClr val="0A7355"/>
+                </a:solidFill>
+                <a:latin typeface="Calibri" pitchFamily="34" charset="0"/>
+                <a:ea typeface="Calibri" pitchFamily="34" charset="-122"/>
+                <a:cs typeface="Calibri" pitchFamily="34" charset="-120"/>
+              </a:rPr>
+              <a:t>AI hub CI/CD (GitOps spine)</a:t>
+            </a:r>
+            <a:endParaRPr lang="en-US" sz="1250" dirty="0"/>
+          </a:p>
+        </p:txBody>
+      </p:sp>
+      <p:sp>
+        <p:nvSpPr>
+          <p:cNvPr id="28" name="Shape 21"/>
+          <p:cNvSpPr/>
+          <p:nvPr/>
+        </p:nvSpPr>
+        <p:spPr>
+          <a:xfrm>
+            <a:off x="4681728" y="1645920"/>
+            <a:ext cx="3163824" cy="731520"/>
+          </a:xfrm>
+          <a:prstGeom prst="roundRect">
+            <a:avLst>
+              <a:gd name="adj" fmla="val 10000"/>
+            </a:avLst>
+          </a:prstGeom>
+          <a:solidFill>
+            <a:srgbClr val="FFFFFF"/>
+          </a:solidFill>
+          <a:ln w="15875">
+            <a:solidFill>
+              <a:srgbClr val="C7D2E8"/>
+            </a:solidFill>
+            <a:prstDash val="solid"/>
+          </a:ln>
+        </p:spPr>
+      </p:sp>
       <p:pic>
         <p:nvPicPr>
-          <p:cNvPr id="31" name="Image 5" descr="preencoded.png">    </p:cNvPr>
+          <p:cNvPr id="29" name="Image 5" descr="preencoded.png">    </p:cNvPr>
           <p:cNvPicPr>
             <a:picLocks noChangeAspect="1"/>
           </p:cNvPicPr>
@@ -11931,7 +11883,7 @@
         </p:blipFill>
         <p:spPr>
           <a:xfrm>
-            <a:off x="4809744" y="3790188"/>
+            <a:off x="4809744" y="1911096"/>
             <a:ext cx="201168" cy="201168"/>
           </a:xfrm>
           <a:prstGeom prst="rect">
@@ -11941,14 +11893,14 @@
       </p:pic>
       <p:sp>
         <p:nvSpPr>
-          <p:cNvPr id="32" name="Text 24"/>
+          <p:cNvPr id="30" name="Text 22"/>
           <p:cNvSpPr txBox="1"/>
           <p:nvPr/>
         </p:nvSpPr>
         <p:spPr>
           <a:xfrm>
-            <a:off x="5120640" y="3547872"/>
-            <a:ext cx="2615184" cy="685800"/>
+            <a:off x="5120640" y="1645920"/>
+            <a:ext cx="2615184" cy="731520"/>
           </a:xfrm>
           <a:prstGeom prst="rect">
             <a:avLst/>
@@ -11975,7 +11927,7 @@
                 <a:ea typeface="Calibri" pitchFamily="34" charset="-122"/>
                 <a:cs typeface="Calibri" pitchFamily="34" charset="-120"/>
               </a:rPr>
-              <a:t>decK gateway sync</a:t>
+              <a:t>GitOps PR in kong-services</a:t>
             </a:r>
             <a:endParaRPr lang="en-US" sz="1150" dirty="0"/>
           </a:p>
@@ -11995,7 +11947,7 @@
                 <a:ea typeface="Calibri" pitchFamily="34" charset="-122"/>
                 <a:cs typeface="Calibri" pitchFamily="34" charset="-120"/>
               </a:rPr>
-              <a:t>Config promoted to the data plane</a:t>
+              <a:t>Declarative config change proposed</a:t>
             </a:r>
             <a:endParaRPr lang="en-US" sz="1150" dirty="0"/>
           </a:p>
@@ -12003,18 +11955,42 @@
       </p:sp>
       <p:sp>
         <p:nvSpPr>
-          <p:cNvPr id="33" name="Shape 25"/>
-          <p:cNvSpPr/>
-          <p:nvPr/>
-        </p:nvSpPr>
-        <p:spPr>
-          <a:xfrm>
-            <a:off x="8503920" y="868680"/>
-            <a:ext cx="3246120" cy="3611880"/>
+          <p:cNvPr id="31" name="Shape 23"/>
+          <p:cNvSpPr/>
+          <p:nvPr/>
+        </p:nvSpPr>
+        <p:spPr>
+          <a:xfrm>
+            <a:off x="6263640" y="2414016"/>
+            <a:ext cx="0" cy="237744"/>
+          </a:xfrm>
+          <a:prstGeom prst="line">
+            <a:avLst/>
+          </a:prstGeom>
+          <a:noFill/>
+          <a:ln w="22225">
+            <a:solidFill>
+              <a:srgbClr val="2B3A67"/>
+            </a:solidFill>
+            <a:prstDash val="solid"/>
+            <a:tailEnd type="triangle"/>
+          </a:ln>
+        </p:spPr>
+      </p:sp>
+      <p:sp>
+        <p:nvSpPr>
+          <p:cNvPr id="32" name="Shape 24"/>
+          <p:cNvSpPr/>
+          <p:nvPr/>
+        </p:nvSpPr>
+        <p:spPr>
+          <a:xfrm>
+            <a:off x="4681728" y="2697480"/>
+            <a:ext cx="3163824" cy="731520"/>
           </a:xfrm>
           <a:prstGeom prst="roundRect">
             <a:avLst>
-              <a:gd name="adj" fmla="val 3380"/>
+              <a:gd name="adj" fmla="val 10000"/>
             </a:avLst>
           </a:prstGeom>
           <a:solidFill>
@@ -12028,166 +12004,9 @@
           </a:ln>
         </p:spPr>
       </p:sp>
-      <p:sp>
-        <p:nvSpPr>
-          <p:cNvPr id="34" name="Shape 26"/>
-          <p:cNvSpPr/>
-          <p:nvPr/>
-        </p:nvSpPr>
-        <p:spPr>
-          <a:xfrm>
-            <a:off x="8631936" y="1024128"/>
-            <a:ext cx="2990088" cy="502920"/>
-          </a:xfrm>
-          <a:prstGeom prst="roundRect">
-            <a:avLst>
-              <a:gd name="adj" fmla="val 14545"/>
-            </a:avLst>
-          </a:prstGeom>
-          <a:solidFill>
-            <a:srgbClr val="F4F2FD"/>
-          </a:solidFill>
-          <a:ln w="15875">
-            <a:solidFill>
-              <a:srgbClr val="D8D2F2"/>
-            </a:solidFill>
-            <a:prstDash val="solid"/>
-          </a:ln>
-        </p:spPr>
-      </p:sp>
-      <p:sp>
-        <p:nvSpPr>
-          <p:cNvPr id="35" name="Shape 27"/>
-          <p:cNvSpPr/>
-          <p:nvPr/>
-        </p:nvSpPr>
-        <p:spPr>
-          <a:xfrm>
-            <a:off x="8723376" y="1097280"/>
-            <a:ext cx="347472" cy="347472"/>
-          </a:xfrm>
-          <a:prstGeom prst="ellipse">
-            <a:avLst/>
-          </a:prstGeom>
-          <a:solidFill>
-            <a:srgbClr val="6D28D9"/>
-          </a:solidFill>
-          <a:ln w="12700">
-            <a:solidFill>
-              <a:srgbClr val="6D28D9"/>
-            </a:solidFill>
-            <a:prstDash val="solid"/>
-          </a:ln>
-        </p:spPr>
-      </p:sp>
-      <p:sp>
-        <p:nvSpPr>
-          <p:cNvPr id="36" name="Text 28"/>
-          <p:cNvSpPr txBox="1"/>
-          <p:nvPr/>
-        </p:nvSpPr>
-        <p:spPr>
-          <a:xfrm>
-            <a:off x="8723376" y="1097280"/>
-            <a:ext cx="347472" cy="347472"/>
-          </a:xfrm>
-          <a:prstGeom prst="rect">
-            <a:avLst/>
-          </a:prstGeom>
-          <a:noFill/>
-          <a:ln/>
-        </p:spPr>
-        <p:txBody>
-          <a:bodyPr wrap="square" lIns="0" tIns="0" rIns="0" bIns="0" rtlCol="0" anchor="ctr"/>
-          <a:lstStyle/>
-          <a:p>
-            <a:pPr algn="ctr" indent="0" marL="0">
-              <a:buNone/>
-            </a:pPr>
-            <a:r>
-              <a:rPr lang="en-US" sz="1300" b="1" dirty="0">
-                <a:solidFill>
-                  <a:srgbClr val="FFFFFF"/>
-                </a:solidFill>
-                <a:latin typeface="Calibri" pitchFamily="34" charset="0"/>
-                <a:ea typeface="Calibri" pitchFamily="34" charset="-122"/>
-                <a:cs typeface="Calibri" pitchFamily="34" charset="-120"/>
-              </a:rPr>
-              <a:t>3</a:t>
-            </a:r>
-            <a:endParaRPr lang="en-US" sz="1300" dirty="0"/>
-          </a:p>
-        </p:txBody>
-      </p:sp>
-      <p:sp>
-        <p:nvSpPr>
-          <p:cNvPr id="37" name="Text 29"/>
-          <p:cNvSpPr txBox="1"/>
-          <p:nvPr/>
-        </p:nvSpPr>
-        <p:spPr>
-          <a:xfrm>
-            <a:off x="9180576" y="1024128"/>
-            <a:ext cx="2423160" cy="502920"/>
-          </a:xfrm>
-          <a:prstGeom prst="rect">
-            <a:avLst/>
-          </a:prstGeom>
-          <a:noFill/>
-          <a:ln/>
-        </p:spPr>
-        <p:txBody>
-          <a:bodyPr wrap="square" lIns="0" tIns="0" rIns="0" bIns="0" rtlCol="0" anchor="ctr"/>
-          <a:lstStyle/>
-          <a:p>
-            <a:pPr indent="0" marL="0">
-              <a:buNone/>
-            </a:pPr>
-            <a:r>
-              <a:rPr lang="en-US" sz="1250" b="1" dirty="0">
-                <a:solidFill>
-                  <a:srgbClr val="5B21B6"/>
-                </a:solidFill>
-                <a:latin typeface="Calibri" pitchFamily="34" charset="0"/>
-                <a:ea typeface="Calibri" pitchFamily="34" charset="-122"/>
-                <a:cs typeface="Calibri" pitchFamily="34" charset="-120"/>
-              </a:rPr>
-              <a:t>Enforced at the data plane</a:t>
-            </a:r>
-            <a:endParaRPr lang="en-US" sz="1250" dirty="0"/>
-          </a:p>
-        </p:txBody>
-      </p:sp>
-      <p:sp>
-        <p:nvSpPr>
-          <p:cNvPr id="38" name="Shape 30"/>
-          <p:cNvSpPr/>
-          <p:nvPr/>
-        </p:nvSpPr>
-        <p:spPr>
-          <a:xfrm>
-            <a:off x="8705088" y="1645920"/>
-            <a:ext cx="2843784" cy="548640"/>
-          </a:xfrm>
-          <a:prstGeom prst="roundRect">
-            <a:avLst>
-              <a:gd name="adj" fmla="val 13333"/>
-            </a:avLst>
-          </a:prstGeom>
-          <a:solidFill>
-            <a:srgbClr val="FFFFFF"/>
-          </a:solidFill>
-          <a:ln w="15875">
-            <a:solidFill>
-              <a:srgbClr val="C7D2E8"/>
-            </a:solidFill>
-            <a:prstDash val="solid"/>
-          </a:ln>
-        </p:spPr>
-      </p:sp>
       <p:pic>
         <p:nvPicPr>
-          <p:cNvPr id="39" name="Image 6" descr="preencoded.png">    </p:cNvPr>
+          <p:cNvPr id="33" name="Image 6" descr="preencoded.png">    </p:cNvPr>
           <p:cNvPicPr>
             <a:picLocks noChangeAspect="1"/>
           </p:cNvPicPr>
@@ -12201,7 +12020,7 @@
         </p:blipFill>
         <p:spPr>
           <a:xfrm>
-            <a:off x="8833104" y="1819656"/>
+            <a:off x="4809744" y="2962656"/>
             <a:ext cx="201168" cy="201168"/>
           </a:xfrm>
           <a:prstGeom prst="rect">
@@ -12211,14 +12030,14 @@
       </p:pic>
       <p:sp>
         <p:nvSpPr>
-          <p:cNvPr id="40" name="Text 31"/>
+          <p:cNvPr id="34" name="Text 25"/>
           <p:cNvSpPr txBox="1"/>
           <p:nvPr/>
         </p:nvSpPr>
         <p:spPr>
           <a:xfrm>
-            <a:off x="9144000" y="1645920"/>
-            <a:ext cx="2295144" cy="548640"/>
+            <a:off x="5120640" y="2697480"/>
+            <a:ext cx="2615184" cy="731520"/>
           </a:xfrm>
           <a:prstGeom prst="rect">
             <a:avLst/>
@@ -12237,7 +12056,7 @@
               <a:buNone/>
             </a:pPr>
             <a:r>
-              <a:rPr lang="en-US" sz="1150" dirty="0">
+              <a:rPr lang="en-US" sz="1150" b="1" dirty="0">
                 <a:solidFill>
                   <a:srgbClr val="1F2937"/>
                 </a:solidFill>
@@ -12245,26 +12064,70 @@
                 <a:ea typeface="Calibri" pitchFamily="34" charset="-122"/>
                 <a:cs typeface="Calibri" pitchFamily="34" charset="-120"/>
               </a:rPr>
-              <a:t>SPIFFE workload attestation</a:t>
+              <a:t>Automated policy &amp; 2LoA vetting</a:t>
             </a:r>
             <a:endParaRPr lang="en-US" sz="1150" dirty="0"/>
           </a:p>
-        </p:txBody>
-      </p:sp>
-      <p:sp>
-        <p:nvSpPr>
-          <p:cNvPr id="41" name="Shape 32"/>
-          <p:cNvSpPr/>
-          <p:nvPr/>
-        </p:nvSpPr>
-        <p:spPr>
-          <a:xfrm>
-            <a:off x="8705088" y="2331720"/>
-            <a:ext cx="2843784" cy="548640"/>
+          <a:p>
+            <a:pPr algn="ctr" indent="0" marL="0">
+              <a:lnSpc>
+                <a:spcPct val="100000"/>
+              </a:lnSpc>
+              <a:buNone/>
+            </a:pPr>
+            <a:r>
+              <a:rPr lang="en-US" sz="950" dirty="0">
+                <a:solidFill>
+                  <a:srgbClr val="4B5563"/>
+                </a:solidFill>
+                <a:latin typeface="Calibri" pitchFamily="34" charset="0"/>
+                <a:ea typeface="Calibri" pitchFamily="34" charset="-122"/>
+                <a:cs typeface="Calibri" pitchFamily="34" charset="-120"/>
+              </a:rPr>
+              <a:t>Schema checks and dual approval</a:t>
+            </a:r>
+            <a:endParaRPr lang="en-US" sz="1150" dirty="0"/>
+          </a:p>
+        </p:txBody>
+      </p:sp>
+      <p:sp>
+        <p:nvSpPr>
+          <p:cNvPr id="35" name="Shape 26"/>
+          <p:cNvSpPr/>
+          <p:nvPr/>
+        </p:nvSpPr>
+        <p:spPr>
+          <a:xfrm>
+            <a:off x="6263640" y="3465576"/>
+            <a:ext cx="0" cy="237744"/>
+          </a:xfrm>
+          <a:prstGeom prst="line">
+            <a:avLst/>
+          </a:prstGeom>
+          <a:noFill/>
+          <a:ln w="22225">
+            <a:solidFill>
+              <a:srgbClr val="2B3A67"/>
+            </a:solidFill>
+            <a:prstDash val="solid"/>
+            <a:tailEnd type="triangle"/>
+          </a:ln>
+        </p:spPr>
+      </p:sp>
+      <p:sp>
+        <p:nvSpPr>
+          <p:cNvPr id="36" name="Shape 27"/>
+          <p:cNvSpPr/>
+          <p:nvPr/>
+        </p:nvSpPr>
+        <p:spPr>
+          <a:xfrm>
+            <a:off x="4681728" y="3749040"/>
+            <a:ext cx="3163824" cy="731520"/>
           </a:xfrm>
           <a:prstGeom prst="roundRect">
             <a:avLst>
-              <a:gd name="adj" fmla="val 13333"/>
+              <a:gd name="adj" fmla="val 10000"/>
             </a:avLst>
           </a:prstGeom>
           <a:solidFill>
@@ -12280,7 +12143,7 @@
       </p:sp>
       <p:pic>
         <p:nvPicPr>
-          <p:cNvPr id="42" name="Image 7" descr="preencoded.png">    </p:cNvPr>
+          <p:cNvPr id="37" name="Image 7" descr="preencoded.png">    </p:cNvPr>
           <p:cNvPicPr>
             <a:picLocks noChangeAspect="1"/>
           </p:cNvPicPr>
@@ -12294,7 +12157,7 @@
         </p:blipFill>
         <p:spPr>
           <a:xfrm>
-            <a:off x="8833104" y="2505456"/>
+            <a:off x="4809744" y="4014216"/>
             <a:ext cx="201168" cy="201168"/>
           </a:xfrm>
           <a:prstGeom prst="rect">
@@ -12302,6 +12165,186 @@
           </a:prstGeom>
         </p:spPr>
       </p:pic>
+      <p:sp>
+        <p:nvSpPr>
+          <p:cNvPr id="38" name="Text 28"/>
+          <p:cNvSpPr txBox="1"/>
+          <p:nvPr/>
+        </p:nvSpPr>
+        <p:spPr>
+          <a:xfrm>
+            <a:off x="5120640" y="3749040"/>
+            <a:ext cx="2615184" cy="731520"/>
+          </a:xfrm>
+          <a:prstGeom prst="rect">
+            <a:avLst/>
+          </a:prstGeom>
+          <a:noFill/>
+          <a:ln/>
+        </p:spPr>
+        <p:txBody>
+          <a:bodyPr wrap="square" lIns="0" tIns="0" rIns="0" bIns="0" rtlCol="0" anchor="ctr"/>
+          <a:lstStyle/>
+          <a:p>
+            <a:pPr algn="ctr" indent="0" marL="0">
+              <a:lnSpc>
+                <a:spcPct val="100000"/>
+              </a:lnSpc>
+              <a:buNone/>
+            </a:pPr>
+            <a:r>
+              <a:rPr lang="en-US" sz="1150" b="1" dirty="0">
+                <a:solidFill>
+                  <a:srgbClr val="1F2937"/>
+                </a:solidFill>
+                <a:latin typeface="Calibri" pitchFamily="34" charset="0"/>
+                <a:ea typeface="Calibri" pitchFamily="34" charset="-122"/>
+                <a:cs typeface="Calibri" pitchFamily="34" charset="-120"/>
+              </a:rPr>
+              <a:t>decK gateway sync</a:t>
+            </a:r>
+            <a:endParaRPr lang="en-US" sz="1150" dirty="0"/>
+          </a:p>
+          <a:p>
+            <a:pPr algn="ctr" indent="0" marL="0">
+              <a:lnSpc>
+                <a:spcPct val="100000"/>
+              </a:lnSpc>
+              <a:buNone/>
+            </a:pPr>
+            <a:r>
+              <a:rPr lang="en-US" sz="950" dirty="0">
+                <a:solidFill>
+                  <a:srgbClr val="4B5563"/>
+                </a:solidFill>
+                <a:latin typeface="Calibri" pitchFamily="34" charset="0"/>
+                <a:ea typeface="Calibri" pitchFamily="34" charset="-122"/>
+                <a:cs typeface="Calibri" pitchFamily="34" charset="-120"/>
+              </a:rPr>
+              <a:t>Config promoted to the data plane</a:t>
+            </a:r>
+            <a:endParaRPr lang="en-US" sz="1150" dirty="0"/>
+          </a:p>
+        </p:txBody>
+      </p:sp>
+      <p:sp>
+        <p:nvSpPr>
+          <p:cNvPr id="39" name="Shape 29"/>
+          <p:cNvSpPr/>
+          <p:nvPr/>
+        </p:nvSpPr>
+        <p:spPr>
+          <a:xfrm>
+            <a:off x="8503920" y="868680"/>
+            <a:ext cx="3246120" cy="3749040"/>
+          </a:xfrm>
+          <a:prstGeom prst="roundRect">
+            <a:avLst>
+              <a:gd name="adj" fmla="val 3380"/>
+            </a:avLst>
+          </a:prstGeom>
+          <a:solidFill>
+            <a:srgbClr val="FFFFFF"/>
+          </a:solidFill>
+          <a:ln w="15875">
+            <a:solidFill>
+              <a:srgbClr val="C7D2E8"/>
+            </a:solidFill>
+            <a:prstDash val="solid"/>
+          </a:ln>
+        </p:spPr>
+      </p:sp>
+      <p:sp>
+        <p:nvSpPr>
+          <p:cNvPr id="40" name="Shape 30"/>
+          <p:cNvSpPr/>
+          <p:nvPr/>
+        </p:nvSpPr>
+        <p:spPr>
+          <a:xfrm>
+            <a:off x="8631936" y="1024128"/>
+            <a:ext cx="2990088" cy="502920"/>
+          </a:xfrm>
+          <a:prstGeom prst="roundRect">
+            <a:avLst>
+              <a:gd name="adj" fmla="val 14545"/>
+            </a:avLst>
+          </a:prstGeom>
+          <a:solidFill>
+            <a:srgbClr val="F4F2FD"/>
+          </a:solidFill>
+          <a:ln w="15875">
+            <a:solidFill>
+              <a:srgbClr val="D8D2F2"/>
+            </a:solidFill>
+            <a:prstDash val="solid"/>
+          </a:ln>
+        </p:spPr>
+      </p:sp>
+      <p:sp>
+        <p:nvSpPr>
+          <p:cNvPr id="41" name="Shape 31"/>
+          <p:cNvSpPr/>
+          <p:nvPr/>
+        </p:nvSpPr>
+        <p:spPr>
+          <a:xfrm>
+            <a:off x="8723376" y="1097280"/>
+            <a:ext cx="347472" cy="347472"/>
+          </a:xfrm>
+          <a:prstGeom prst="ellipse">
+            <a:avLst/>
+          </a:prstGeom>
+          <a:solidFill>
+            <a:srgbClr val="6D28D9"/>
+          </a:solidFill>
+          <a:ln w="12700">
+            <a:solidFill>
+              <a:srgbClr val="6D28D9"/>
+            </a:solidFill>
+            <a:prstDash val="solid"/>
+          </a:ln>
+        </p:spPr>
+      </p:sp>
+      <p:sp>
+        <p:nvSpPr>
+          <p:cNvPr id="42" name="Text 32"/>
+          <p:cNvSpPr txBox="1"/>
+          <p:nvPr/>
+        </p:nvSpPr>
+        <p:spPr>
+          <a:xfrm>
+            <a:off x="8723376" y="1097280"/>
+            <a:ext cx="347472" cy="347472"/>
+          </a:xfrm>
+          <a:prstGeom prst="rect">
+            <a:avLst/>
+          </a:prstGeom>
+          <a:noFill/>
+          <a:ln/>
+        </p:spPr>
+        <p:txBody>
+          <a:bodyPr wrap="square" lIns="0" tIns="0" rIns="0" bIns="0" rtlCol="0" anchor="ctr"/>
+          <a:lstStyle/>
+          <a:p>
+            <a:pPr algn="ctr" indent="0" marL="0">
+              <a:buNone/>
+            </a:pPr>
+            <a:r>
+              <a:rPr lang="en-US" sz="1300" b="1" dirty="0">
+                <a:solidFill>
+                  <a:srgbClr val="FFFFFF"/>
+                </a:solidFill>
+                <a:latin typeface="Calibri" pitchFamily="34" charset="0"/>
+                <a:ea typeface="Calibri" pitchFamily="34" charset="-122"/>
+                <a:cs typeface="Calibri" pitchFamily="34" charset="-120"/>
+              </a:rPr>
+              <a:t>3</a:t>
+            </a:r>
+            <a:endParaRPr lang="en-US" sz="1300" dirty="0"/>
+          </a:p>
+        </p:txBody>
+      </p:sp>
       <p:sp>
         <p:nvSpPr>
           <p:cNvPr id="43" name="Text 33"/>
@@ -12310,8 +12353,8 @@
         </p:nvSpPr>
         <p:spPr>
           <a:xfrm>
-            <a:off x="9144000" y="2331720"/>
-            <a:ext cx="2295144" cy="548640"/>
+            <a:off x="9180576" y="1024128"/>
+            <a:ext cx="2423160" cy="502920"/>
           </a:xfrm>
           <a:prstGeom prst="rect">
             <a:avLst/>
@@ -12323,24 +12366,21 @@
           <a:bodyPr wrap="square" lIns="0" tIns="0" rIns="0" bIns="0" rtlCol="0" anchor="ctr"/>
           <a:lstStyle/>
           <a:p>
-            <a:pPr algn="ctr" indent="0" marL="0">
-              <a:lnSpc>
-                <a:spcPct val="100000"/>
-              </a:lnSpc>
-              <a:buNone/>
-            </a:pPr>
-            <a:r>
-              <a:rPr lang="en-US" sz="1150" dirty="0">
-                <a:solidFill>
-                  <a:srgbClr val="1F2937"/>
-                </a:solidFill>
-                <a:latin typeface="Calibri" pitchFamily="34" charset="0"/>
-                <a:ea typeface="Calibri" pitchFamily="34" charset="-122"/>
-                <a:cs typeface="Calibri" pitchFamily="34" charset="-120"/>
-              </a:rPr>
-              <a:t>Central Splunk HEC telemetry</a:t>
-            </a:r>
-            <a:endParaRPr lang="en-US" sz="1150" dirty="0"/>
+            <a:pPr indent="0" marL="0">
+              <a:buNone/>
+            </a:pPr>
+            <a:r>
+              <a:rPr lang="en-US" sz="1250" b="1" dirty="0">
+                <a:solidFill>
+                  <a:srgbClr val="5B21B6"/>
+                </a:solidFill>
+                <a:latin typeface="Calibri" pitchFamily="34" charset="0"/>
+                <a:ea typeface="Calibri" pitchFamily="34" charset="-122"/>
+                <a:cs typeface="Calibri" pitchFamily="34" charset="-120"/>
+              </a:rPr>
+              <a:t>Enforced at the data plane</a:t>
+            </a:r>
+            <a:endParaRPr lang="en-US" sz="1250" dirty="0"/>
           </a:p>
         </p:txBody>
       </p:sp>
@@ -12352,12 +12392,12 @@
         </p:nvSpPr>
         <p:spPr>
           <a:xfrm>
-            <a:off x="8705088" y="3017520"/>
-            <a:ext cx="2843784" cy="548640"/>
+            <a:off x="8705088" y="1645920"/>
+            <a:ext cx="2843784" cy="585216"/>
           </a:xfrm>
           <a:prstGeom prst="roundRect">
             <a:avLst>
-              <a:gd name="adj" fmla="val 13333"/>
+              <a:gd name="adj" fmla="val 12500"/>
             </a:avLst>
           </a:prstGeom>
           <a:solidFill>
@@ -12387,7 +12427,7 @@
         </p:blipFill>
         <p:spPr>
           <a:xfrm>
-            <a:off x="8833104" y="3191256"/>
+            <a:off x="8833104" y="1837944"/>
             <a:ext cx="201168" cy="201168"/>
           </a:xfrm>
           <a:prstGeom prst="rect">
@@ -12403,8 +12443,8 @@
         </p:nvSpPr>
         <p:spPr>
           <a:xfrm>
-            <a:off x="9144000" y="3017520"/>
-            <a:ext cx="2295144" cy="548640"/>
+            <a:off x="9144000" y="1645920"/>
+            <a:ext cx="2295144" cy="585216"/>
           </a:xfrm>
           <a:prstGeom prst="rect">
             <a:avLst/>
@@ -12431,7 +12471,7 @@
                 <a:ea typeface="Calibri" pitchFamily="34" charset="-122"/>
                 <a:cs typeface="Calibri" pitchFamily="34" charset="-120"/>
               </a:rPr>
-              <a:t>Token quotas &amp; loop defenses</a:t>
+              <a:t>SPIFFE workload attestation</a:t>
             </a:r>
             <a:endParaRPr lang="en-US" sz="1150" dirty="0"/>
           </a:p>
@@ -12445,12 +12485,12 @@
         </p:nvSpPr>
         <p:spPr>
           <a:xfrm>
-            <a:off x="8705088" y="3703320"/>
-            <a:ext cx="2843784" cy="548640"/>
+            <a:off x="8705088" y="2395728"/>
+            <a:ext cx="2843784" cy="585216"/>
           </a:xfrm>
           <a:prstGeom prst="roundRect">
             <a:avLst>
-              <a:gd name="adj" fmla="val 13333"/>
+              <a:gd name="adj" fmla="val 12500"/>
             </a:avLst>
           </a:prstGeom>
           <a:solidFill>
@@ -12480,7 +12520,7 @@
         </p:blipFill>
         <p:spPr>
           <a:xfrm>
-            <a:off x="8833104" y="3877056"/>
+            <a:off x="8833104" y="2587752"/>
             <a:ext cx="201168" cy="201168"/>
           </a:xfrm>
           <a:prstGeom prst="rect">
@@ -12496,8 +12536,8 @@
         </p:nvSpPr>
         <p:spPr>
           <a:xfrm>
-            <a:off x="9144000" y="3703320"/>
-            <a:ext cx="2295144" cy="548640"/>
+            <a:off x="9144000" y="2395728"/>
+            <a:ext cx="2295144" cy="585216"/>
           </a:xfrm>
           <a:prstGeom prst="rect">
             <a:avLst/>
@@ -12524,7 +12564,7 @@
                 <a:ea typeface="Calibri" pitchFamily="34" charset="-122"/>
                 <a:cs typeface="Calibri" pitchFamily="34" charset="-120"/>
               </a:rPr>
-              <a:t>Dynamic vault secrets &amp; tool ACLs</a:t>
+              <a:t>Central Splunk HEC telemetry</a:t>
             </a:r>
             <a:endParaRPr lang="en-US" sz="1150" dirty="0"/>
           </a:p>
@@ -12538,68 +12578,20 @@
         </p:nvSpPr>
         <p:spPr>
           <a:xfrm>
-            <a:off x="4114800" y="2651760"/>
-            <a:ext cx="292608" cy="0"/>
-          </a:xfrm>
-          <a:prstGeom prst="line">
-            <a:avLst/>
-          </a:prstGeom>
-          <a:noFill/>
-          <a:ln w="25400">
-            <a:solidFill>
-              <a:srgbClr val="2B3A67"/>
-            </a:solidFill>
-            <a:prstDash val="solid"/>
-            <a:tailEnd type="triangle"/>
-          </a:ln>
-        </p:spPr>
-      </p:sp>
-      <p:sp>
-        <p:nvSpPr>
-          <p:cNvPr id="51" name="Shape 39"/>
-          <p:cNvSpPr/>
-          <p:nvPr/>
-        </p:nvSpPr>
-        <p:spPr>
-          <a:xfrm>
-            <a:off x="8138160" y="2651760"/>
-            <a:ext cx="292608" cy="0"/>
-          </a:xfrm>
-          <a:prstGeom prst="line">
-            <a:avLst/>
-          </a:prstGeom>
-          <a:noFill/>
-          <a:ln w="25400">
-            <a:solidFill>
-              <a:srgbClr val="2B3A67"/>
-            </a:solidFill>
-            <a:prstDash val="solid"/>
-            <a:tailEnd type="triangle"/>
-          </a:ln>
-        </p:spPr>
-      </p:sp>
-      <p:sp>
-        <p:nvSpPr>
-          <p:cNvPr id="52" name="Shape 40"/>
-          <p:cNvSpPr/>
-          <p:nvPr/>
-        </p:nvSpPr>
-        <p:spPr>
-          <a:xfrm>
-            <a:off x="457200" y="4754880"/>
-            <a:ext cx="7589520" cy="960120"/>
+            <a:off x="8705088" y="3145536"/>
+            <a:ext cx="2843784" cy="585216"/>
           </a:xfrm>
           <a:prstGeom prst="roundRect">
             <a:avLst>
-              <a:gd name="adj" fmla="val 9524"/>
+              <a:gd name="adj" fmla="val 12500"/>
             </a:avLst>
           </a:prstGeom>
           <a:solidFill>
-            <a:srgbClr val="FDF1F1"/>
+            <a:srgbClr val="FFFFFF"/>
           </a:solidFill>
           <a:ln w="15875">
             <a:solidFill>
-              <a:srgbClr val="F0C3C3"/>
+              <a:srgbClr val="C7D2E8"/>
             </a:solidFill>
             <a:prstDash val="solid"/>
           </a:ln>
@@ -12607,7 +12599,7 @@
       </p:sp>
       <p:pic>
         <p:nvPicPr>
-          <p:cNvPr id="53" name="Image 10" descr="preencoded.png">    </p:cNvPr>
+          <p:cNvPr id="51" name="Image 10" descr="preencoded.png">    </p:cNvPr>
           <p:cNvPicPr>
             <a:picLocks noChangeAspect="1"/>
           </p:cNvPicPr>
@@ -12621,8 +12613,8 @@
         </p:blipFill>
         <p:spPr>
           <a:xfrm>
-            <a:off x="685800" y="5102352"/>
-            <a:ext cx="256032" cy="256032"/>
+            <a:off x="8833104" y="3337560"/>
+            <a:ext cx="201168" cy="201168"/>
           </a:xfrm>
           <a:prstGeom prst="rect">
             <a:avLst/>
@@ -12631,14 +12623,14 @@
       </p:pic>
       <p:sp>
         <p:nvSpPr>
-          <p:cNvPr id="54" name="Text 41"/>
+          <p:cNvPr id="52" name="Text 39"/>
           <p:cNvSpPr txBox="1"/>
           <p:nvPr/>
         </p:nvSpPr>
         <p:spPr>
           <a:xfrm>
-            <a:off x="1033272" y="5029200"/>
-            <a:ext cx="2011680" cy="411480"/>
+            <a:off x="9144000" y="3145536"/>
+            <a:ext cx="2295144" cy="585216"/>
           </a:xfrm>
           <a:prstGeom prst="rect">
             <a:avLst/>
@@ -12650,38 +12642,41 @@
           <a:bodyPr wrap="square" lIns="0" tIns="0" rIns="0" bIns="0" rtlCol="0" anchor="ctr"/>
           <a:lstStyle/>
           <a:p>
-            <a:pPr indent="0" marL="0">
-              <a:buNone/>
-            </a:pPr>
-            <a:r>
-              <a:rPr lang="en-US" sz="1300" b="1" dirty="0">
-                <a:solidFill>
-                  <a:srgbClr val="B3261E"/>
-                </a:solidFill>
-                <a:latin typeface="Calibri" pitchFamily="34" charset="0"/>
-                <a:ea typeface="Calibri" pitchFamily="34" charset="-122"/>
-                <a:cs typeface="Calibri" pitchFamily="34" charset="-120"/>
-              </a:rPr>
-              <a:t>Emergency operations</a:t>
-            </a:r>
-            <a:endParaRPr lang="en-US" sz="1300" dirty="0"/>
-          </a:p>
-        </p:txBody>
-      </p:sp>
-      <p:sp>
-        <p:nvSpPr>
-          <p:cNvPr id="55" name="Shape 42"/>
-          <p:cNvSpPr/>
-          <p:nvPr/>
-        </p:nvSpPr>
-        <p:spPr>
-          <a:xfrm>
-            <a:off x="3154680" y="4992624"/>
-            <a:ext cx="4663440" cy="484632"/>
+            <a:pPr algn="ctr" indent="0" marL="0">
+              <a:lnSpc>
+                <a:spcPct val="100000"/>
+              </a:lnSpc>
+              <a:buNone/>
+            </a:pPr>
+            <a:r>
+              <a:rPr lang="en-US" sz="1150" dirty="0">
+                <a:solidFill>
+                  <a:srgbClr val="1F2937"/>
+                </a:solidFill>
+                <a:latin typeface="Calibri" pitchFamily="34" charset="0"/>
+                <a:ea typeface="Calibri" pitchFamily="34" charset="-122"/>
+                <a:cs typeface="Calibri" pitchFamily="34" charset="-120"/>
+              </a:rPr>
+              <a:t>Token quotas &amp; loop defenses</a:t>
+            </a:r>
+            <a:endParaRPr lang="en-US" sz="1150" dirty="0"/>
+          </a:p>
+        </p:txBody>
+      </p:sp>
+      <p:sp>
+        <p:nvSpPr>
+          <p:cNvPr id="53" name="Shape 40"/>
+          <p:cNvSpPr/>
+          <p:nvPr/>
+        </p:nvSpPr>
+        <p:spPr>
+          <a:xfrm>
+            <a:off x="8705088" y="3895344"/>
+            <a:ext cx="2843784" cy="585216"/>
           </a:xfrm>
           <a:prstGeom prst="roundRect">
             <a:avLst>
-              <a:gd name="adj" fmla="val 15094"/>
+              <a:gd name="adj" fmla="val 12500"/>
             </a:avLst>
           </a:prstGeom>
           <a:solidFill>
@@ -12689,7 +12684,7 @@
           </a:solidFill>
           <a:ln w="15875">
             <a:solidFill>
-              <a:srgbClr val="F0C3C3"/>
+              <a:srgbClr val="C7D2E8"/>
             </a:solidFill>
             <a:prstDash val="solid"/>
           </a:ln>
@@ -12697,7 +12692,7 @@
       </p:sp>
       <p:pic>
         <p:nvPicPr>
-          <p:cNvPr id="56" name="Image 11" descr="preencoded.png">    </p:cNvPr>
+          <p:cNvPr id="54" name="Image 11" descr="preencoded.png">    </p:cNvPr>
           <p:cNvPicPr>
             <a:picLocks noChangeAspect="1"/>
           </p:cNvPicPr>
@@ -12711,8 +12706,8 @@
         </p:blipFill>
         <p:spPr>
           <a:xfrm>
-            <a:off x="3310128" y="5120640"/>
-            <a:ext cx="219456" cy="219456"/>
+            <a:off x="8833104" y="4087368"/>
+            <a:ext cx="201168" cy="201168"/>
           </a:xfrm>
           <a:prstGeom prst="rect">
             <a:avLst/>
@@ -12721,14 +12716,14 @@
       </p:pic>
       <p:sp>
         <p:nvSpPr>
-          <p:cNvPr id="57" name="Text 43"/>
+          <p:cNvPr id="55" name="Text 41"/>
           <p:cNvSpPr txBox="1"/>
           <p:nvPr/>
         </p:nvSpPr>
         <p:spPr>
           <a:xfrm>
-            <a:off x="3566160" y="4992624"/>
-            <a:ext cx="4069080" cy="484632"/>
+            <a:off x="9144000" y="3895344"/>
+            <a:ext cx="2295144" cy="585216"/>
           </a:xfrm>
           <a:prstGeom prst="rect">
             <a:avLst/>
@@ -12741,10 +12736,13 @@
           <a:lstStyle/>
           <a:p>
             <a:pPr algn="ctr" indent="0" marL="0">
-              <a:buNone/>
-            </a:pPr>
-            <a:r>
-              <a:rPr lang="en-US" sz="1150" b="1" dirty="0">
+              <a:lnSpc>
+                <a:spcPct val="100000"/>
+              </a:lnSpc>
+              <a:buNone/>
+            </a:pPr>
+            <a:r>
+              <a:rPr lang="en-US" sz="1150" dirty="0">
                 <a:solidFill>
                   <a:srgbClr val="1F2937"/>
                 </a:solidFill>
@@ -12752,7 +12750,7 @@
                 <a:ea typeface="Calibri" pitchFamily="34" charset="-122"/>
                 <a:cs typeface="Calibri" pitchFamily="34" charset="-120"/>
               </a:rPr>
-              <a:t>Automated kill switch API  /  SRE revocation</a:t>
+              <a:t>Dynamic vault secrets &amp; tool ACLs</a:t>
             </a:r>
             <a:endParaRPr lang="en-US" sz="1150" dirty="0"/>
           </a:p>
@@ -12760,38 +12758,62 @@
       </p:sp>
       <p:sp>
         <p:nvSpPr>
+          <p:cNvPr id="56" name="Shape 42"/>
+          <p:cNvSpPr/>
+          <p:nvPr/>
+        </p:nvSpPr>
+        <p:spPr>
+          <a:xfrm>
+            <a:off x="4114800" y="2743200"/>
+            <a:ext cx="292608" cy="0"/>
+          </a:xfrm>
+          <a:prstGeom prst="line">
+            <a:avLst/>
+          </a:prstGeom>
+          <a:noFill/>
+          <a:ln w="25400">
+            <a:solidFill>
+              <a:srgbClr val="2B3A67"/>
+            </a:solidFill>
+            <a:prstDash val="solid"/>
+            <a:tailEnd type="triangle"/>
+          </a:ln>
+        </p:spPr>
+      </p:sp>
+      <p:sp>
+        <p:nvSpPr>
+          <p:cNvPr id="57" name="Shape 43"/>
+          <p:cNvSpPr/>
+          <p:nvPr/>
+        </p:nvSpPr>
+        <p:spPr>
+          <a:xfrm>
+            <a:off x="8138160" y="2743200"/>
+            <a:ext cx="292608" cy="0"/>
+          </a:xfrm>
+          <a:prstGeom prst="line">
+            <a:avLst/>
+          </a:prstGeom>
+          <a:noFill/>
+          <a:ln w="25400">
+            <a:solidFill>
+              <a:srgbClr val="2B3A67"/>
+            </a:solidFill>
+            <a:prstDash val="solid"/>
+            <a:tailEnd type="triangle"/>
+          </a:ln>
+        </p:spPr>
+      </p:sp>
+      <p:sp>
+        <p:nvSpPr>
           <p:cNvPr id="58" name="Shape 44"/>
           <p:cNvSpPr/>
           <p:nvPr/>
         </p:nvSpPr>
         <p:spPr>
           <a:xfrm>
-            <a:off x="8138160" y="5234940"/>
-            <a:ext cx="292608" cy="0"/>
-          </a:xfrm>
-          <a:prstGeom prst="line">
-            <a:avLst/>
-          </a:prstGeom>
-          <a:noFill/>
-          <a:ln w="25400">
-            <a:solidFill>
-              <a:srgbClr val="B3261E"/>
-            </a:solidFill>
-            <a:prstDash val="dash"/>
-            <a:tailEnd type="triangle"/>
-          </a:ln>
-        </p:spPr>
-      </p:sp>
-      <p:sp>
-        <p:nvSpPr>
-          <p:cNvPr id="59" name="Shape 45"/>
-          <p:cNvSpPr/>
-          <p:nvPr/>
-        </p:nvSpPr>
-        <p:spPr>
-          <a:xfrm>
-            <a:off x="8503920" y="4754880"/>
-            <a:ext cx="3246120" cy="960120"/>
+            <a:off x="457200" y="4892040"/>
+            <a:ext cx="7589520" cy="960120"/>
           </a:xfrm>
           <a:prstGeom prst="roundRect">
             <a:avLst>
@@ -12809,15 +12831,219 @@
           </a:ln>
         </p:spPr>
       </p:sp>
-      <p:sp>
-        <p:nvSpPr>
-          <p:cNvPr id="60" name="Text 46"/>
+      <p:pic>
+        <p:nvPicPr>
+          <p:cNvPr id="59" name="Image 12" descr="preencoded.png">    </p:cNvPr>
+          <p:cNvPicPr>
+            <a:picLocks noChangeAspect="1"/>
+          </p:cNvPicPr>
+          <p:nvPr/>
+        </p:nvPicPr>
+        <p:blipFill>
+          <a:blip r:embed="rId13"/>
+          <a:stretch>
+            <a:fillRect/>
+          </a:stretch>
+        </p:blipFill>
+        <p:spPr>
+          <a:xfrm>
+            <a:off x="685800" y="5239512"/>
+            <a:ext cx="256032" cy="256032"/>
+          </a:xfrm>
+          <a:prstGeom prst="rect">
+            <a:avLst/>
+          </a:prstGeom>
+        </p:spPr>
+      </p:pic>
+      <p:sp>
+        <p:nvSpPr>
+          <p:cNvPr id="60" name="Text 45"/>
           <p:cNvSpPr txBox="1"/>
           <p:nvPr/>
         </p:nvSpPr>
         <p:spPr>
           <a:xfrm>
-            <a:off x="8613648" y="4754880"/>
+            <a:off x="1033272" y="5166360"/>
+            <a:ext cx="2011680" cy="411480"/>
+          </a:xfrm>
+          <a:prstGeom prst="rect">
+            <a:avLst/>
+          </a:prstGeom>
+          <a:noFill/>
+          <a:ln/>
+        </p:spPr>
+        <p:txBody>
+          <a:bodyPr wrap="square" lIns="0" tIns="0" rIns="0" bIns="0" rtlCol="0" anchor="ctr"/>
+          <a:lstStyle/>
+          <a:p>
+            <a:pPr indent="0" marL="0">
+              <a:buNone/>
+            </a:pPr>
+            <a:r>
+              <a:rPr lang="en-US" sz="1300" b="1" dirty="0">
+                <a:solidFill>
+                  <a:srgbClr val="B3261E"/>
+                </a:solidFill>
+                <a:latin typeface="Calibri" pitchFamily="34" charset="0"/>
+                <a:ea typeface="Calibri" pitchFamily="34" charset="-122"/>
+                <a:cs typeface="Calibri" pitchFamily="34" charset="-120"/>
+              </a:rPr>
+              <a:t>Emergency operations</a:t>
+            </a:r>
+            <a:endParaRPr lang="en-US" sz="1300" dirty="0"/>
+          </a:p>
+        </p:txBody>
+      </p:sp>
+      <p:sp>
+        <p:nvSpPr>
+          <p:cNvPr id="61" name="Shape 46"/>
+          <p:cNvSpPr/>
+          <p:nvPr/>
+        </p:nvSpPr>
+        <p:spPr>
+          <a:xfrm>
+            <a:off x="3154680" y="5129784"/>
+            <a:ext cx="4663440" cy="484632"/>
+          </a:xfrm>
+          <a:prstGeom prst="roundRect">
+            <a:avLst>
+              <a:gd name="adj" fmla="val 15094"/>
+            </a:avLst>
+          </a:prstGeom>
+          <a:solidFill>
+            <a:srgbClr val="FFFFFF"/>
+          </a:solidFill>
+          <a:ln w="15875">
+            <a:solidFill>
+              <a:srgbClr val="F0C3C3"/>
+            </a:solidFill>
+            <a:prstDash val="solid"/>
+          </a:ln>
+        </p:spPr>
+      </p:sp>
+      <p:pic>
+        <p:nvPicPr>
+          <p:cNvPr id="62" name="Image 13" descr="preencoded.png">    </p:cNvPr>
+          <p:cNvPicPr>
+            <a:picLocks noChangeAspect="1"/>
+          </p:cNvPicPr>
+          <p:nvPr/>
+        </p:nvPicPr>
+        <p:blipFill>
+          <a:blip r:embed="rId14"/>
+          <a:stretch>
+            <a:fillRect/>
+          </a:stretch>
+        </p:blipFill>
+        <p:spPr>
+          <a:xfrm>
+            <a:off x="3310128" y="5257800"/>
+            <a:ext cx="219456" cy="219456"/>
+          </a:xfrm>
+          <a:prstGeom prst="rect">
+            <a:avLst/>
+          </a:prstGeom>
+        </p:spPr>
+      </p:pic>
+      <p:sp>
+        <p:nvSpPr>
+          <p:cNvPr id="63" name="Text 47"/>
+          <p:cNvSpPr txBox="1"/>
+          <p:nvPr/>
+        </p:nvSpPr>
+        <p:spPr>
+          <a:xfrm>
+            <a:off x="3566160" y="5129784"/>
+            <a:ext cx="4069080" cy="484632"/>
+          </a:xfrm>
+          <a:prstGeom prst="rect">
+            <a:avLst/>
+          </a:prstGeom>
+          <a:noFill/>
+          <a:ln/>
+        </p:spPr>
+        <p:txBody>
+          <a:bodyPr wrap="square" lIns="0" tIns="0" rIns="0" bIns="0" rtlCol="0" anchor="ctr"/>
+          <a:lstStyle/>
+          <a:p>
+            <a:pPr algn="ctr" indent="0" marL="0">
+              <a:buNone/>
+            </a:pPr>
+            <a:r>
+              <a:rPr lang="en-US" sz="1150" b="1" dirty="0">
+                <a:solidFill>
+                  <a:srgbClr val="1F2937"/>
+                </a:solidFill>
+                <a:latin typeface="Calibri" pitchFamily="34" charset="0"/>
+                <a:ea typeface="Calibri" pitchFamily="34" charset="-122"/>
+                <a:cs typeface="Calibri" pitchFamily="34" charset="-120"/>
+              </a:rPr>
+              <a:t>Automated kill switch API  /  SRE revocation</a:t>
+            </a:r>
+            <a:endParaRPr lang="en-US" sz="1150" dirty="0"/>
+          </a:p>
+        </p:txBody>
+      </p:sp>
+      <p:sp>
+        <p:nvSpPr>
+          <p:cNvPr id="64" name="Shape 48"/>
+          <p:cNvSpPr/>
+          <p:nvPr/>
+        </p:nvSpPr>
+        <p:spPr>
+          <a:xfrm>
+            <a:off x="8138160" y="5372100"/>
+            <a:ext cx="292608" cy="0"/>
+          </a:xfrm>
+          <a:prstGeom prst="line">
+            <a:avLst/>
+          </a:prstGeom>
+          <a:noFill/>
+          <a:ln w="25400">
+            <a:solidFill>
+              <a:srgbClr val="B3261E"/>
+            </a:solidFill>
+            <a:prstDash val="dash"/>
+            <a:tailEnd type="triangle"/>
+          </a:ln>
+        </p:spPr>
+      </p:sp>
+      <p:sp>
+        <p:nvSpPr>
+          <p:cNvPr id="65" name="Shape 49"/>
+          <p:cNvSpPr/>
+          <p:nvPr/>
+        </p:nvSpPr>
+        <p:spPr>
+          <a:xfrm>
+            <a:off x="8503920" y="4892040"/>
+            <a:ext cx="3246120" cy="960120"/>
+          </a:xfrm>
+          <a:prstGeom prst="roundRect">
+            <a:avLst>
+              <a:gd name="adj" fmla="val 9524"/>
+            </a:avLst>
+          </a:prstGeom>
+          <a:solidFill>
+            <a:srgbClr val="FDF1F1"/>
+          </a:solidFill>
+          <a:ln w="15875">
+            <a:solidFill>
+              <a:srgbClr val="F0C3C3"/>
+            </a:solidFill>
+            <a:prstDash val="solid"/>
+          </a:ln>
+        </p:spPr>
+      </p:sp>
+      <p:sp>
+        <p:nvSpPr>
+          <p:cNvPr id="66" name="Text 50"/>
+          <p:cNvSpPr txBox="1"/>
+          <p:nvPr/>
+        </p:nvSpPr>
+        <p:spPr>
+          <a:xfrm>
+            <a:off x="8613648" y="4892040"/>
             <a:ext cx="3026664" cy="960120"/>
           </a:xfrm>
           <a:prstGeom prst="rect">
@@ -12873,7 +13099,7 @@
       </p:sp>
       <p:sp>
         <p:nvSpPr>
-          <p:cNvPr id="61" name="Shape 47"/>
+          <p:cNvPr id="67" name="Shape 51"/>
           <p:cNvSpPr/>
           <p:nvPr/>
         </p:nvSpPr>
@@ -12900,7 +13126,7 @@
       </p:sp>
       <p:sp>
         <p:nvSpPr>
-          <p:cNvPr id="62" name="Text 48"/>
+          <p:cNvPr id="68" name="Text 52"/>
           <p:cNvSpPr txBox="1"/>
           <p:nvPr/>
         </p:nvSpPr>

</xml_diff>